<commit_message>
Add RDFS graph figure and 4-star transform slide; reassign closing to Part 4
- New shared TikZ figure report/figures/rdfs_graph.tex (lecture-style RDFS
  graph: schema above the line, Cong Phuong instance data below), used as
  report Figure 2 and slide 6 with per-folder colours
- Report: describe property domains/ranges precisely and add a "from three
  to four stars" walkthrough of one infobox; now 15 pages
- Slides: replace the class table with the RDFS graph, add slide 9
  (infobox before/after as 4-star RDF), renumber to 20 slides, closing
  presented by Part 4
- Update speaker notes, READMEs, rebuilt PDFs and PPTX
</commit_message>
<xml_diff>
--- a/slides/Vietnamese-DBpedia-slides.pptx
+++ b/slides/Vietnamese-DBpedia-slides.pptx
@@ -24,6 +24,7 @@
     <p:sldId id="272" r:id="rId24"/>
     <p:sldId id="273" r:id="rId25"/>
     <p:sldId id="274" r:id="rId26"/>
+    <p:sldId id="275" r:id="rId27"/>
   </p:sldIdLst>
   <p:sldSz cx="9144000" cy="6857994" type="screen4x3"/>
   <p:notesSz cx="6858000" cy="9144000"/>
@@ -590,22 +591,12 @@
           <a:lstStyle/>
           <a:p>
             <a:r>
-              <a:t>Nói: Trước khi xuất, tám hàm kiểm tra chạy trên dữ liệu: lần dựng cuối không có lỗi nào. Suy luận thêm 41.730 triple trong 117 giây, nhờ đó truy vấn bằng từ vựng DBpedia mới có kết quả. Suy luận còn bắt được hai lỗi mô hình hoá mà nhóm đã sửa.</a:t>
-            </a:r>
-          </a:p>
-          <a:p>
-            <a:r>
-              <a:t>Số phải trúng: 0 lỗi, 0 cảnh báo; 47 test; +41.730 triple.</a:t>
-            </a:r>
-          </a:p>
-          <a:p>
-            <a:r>
-              <a:t>Nếu bị hỏi về hai lỗi: (1) đội tuyển bị suy ra là CLB vì domain của ground đặt sai; (2) khai báo tenant là nghịch đảo của ground làm sai sân nhà, vì ô "bên thuê" liệt kê mọi đội từng dùng sân.</a:t>
-            </a:r>
-          </a:p>
-          <a:p>
-            <a:r>
-              <a:t>Nếu bị hỏi "sao bỏ owl:sameAs và functional khỏi reasoner?": OWL 2 RL sinh x sameAs x cho mọi nút và gộp các thực thể có cùng giá trị functional; functional được kiểm tra riêng ở bước validation.</a:t>
+              <a:t>Nói: Mình là Dung, phụ trách tầng hậu xử lý. Đây là Nguyễn Công Phượng. Nét xám là dữ liệu khai báo: hai chặng thi đấu, đội, sân nhà Pleiku, tỉnh Gia Lai. Nét đỏ đứt là phần suy luận: các lớp DBpedia, cạnh playedFor, và Mito HollyHock được xếp vào lớp CLB. Nét xanh là liên kết ra ngoài.</a:t>
+            </a:r>
+          </a:p>
+          <a:p>
+            <a:r>
+              <a:t>Số phải trúng: 11 chặng thi đấu; 2015–2023, 103 trận, 36 bàn ở Hoàng Anh Gia Lai.</a:t>
             </a:r>
           </a:p>
         </p:txBody>
@@ -675,17 +666,22 @@
           <a:lstStyle/>
           <a:p>
             <a:r>
-              <a:t>Nói: Liên kết lấy từ sitelink tiếng Anh của chính item Wikidata, không ghép theo tên vì tên Việt trùng nhiều. Có 777 liên kết sang DBpedia và 990 sang Wikidata. Nhóm kiểm tra cả 777 trên DBpedia thật: 733 trỏ đúng bài viết, 44 còn lại lệch vì DBpedia lấy dữ liệu từ bản Wikipedia cũ hơn.</a:t>
-            </a:r>
-          </a:p>
-          <a:p>
-            <a:r>
-              <a:t>Số phải trúng: 777 / 990; 733 (94,3%); 12 đổi hướng, 32 chưa có.</a:t>
-            </a:r>
-          </a:p>
-          <a:p>
-            <a:r>
-              <a:t>Nếu bị hỏi "sửa 44 liên kết thế nào?": 12 cái đi theo dbo:wikiPageRedirects là sửa được; 32 cái phải chờ bản DBpedia mới hoặc kiểm lại sau mỗi lần phát hành.</a:t>
+              <a:t>Nói: Trước khi xuất, tám hàm kiểm tra chạy trên dữ liệu: lần dựng cuối không có lỗi nào. Suy luận thêm 41.730 triple trong 117 giây, nhờ đó truy vấn bằng từ vựng DBpedia mới có kết quả. Suy luận còn bắt được hai lỗi mô hình hoá mà nhóm đã sửa.</a:t>
+            </a:r>
+          </a:p>
+          <a:p>
+            <a:r>
+              <a:t>Số phải trúng: 0 lỗi, 0 cảnh báo; 47 test; +41.730 triple.</a:t>
+            </a:r>
+          </a:p>
+          <a:p>
+            <a:r>
+              <a:t>Nếu bị hỏi về hai lỗi: (1) đội tuyển bị suy ra là CLB vì domain của ground đặt sai; (2) khai báo tenant là nghịch đảo của ground làm sai sân nhà, vì ô "bên thuê" liệt kê mọi đội từng dùng sân.</a:t>
+            </a:r>
+          </a:p>
+          <a:p>
+            <a:r>
+              <a:t>Nếu bị hỏi "sao bỏ owl:sameAs và functional khỏi reasoner?": OWL 2 RL sinh x sameAs x cho mọi nút và gộp các thực thể có cùng giá trị functional; functional được kiểm tra riêng ở bước validation.</a:t>
             </a:r>
           </a:p>
         </p:txBody>
@@ -755,7 +751,17 @@
           <a:lstStyle/>
           <a:p>
             <a:r>
-              <a:t>Nói: Mỗi IRI tra được như DBpedia: máy chủ trả 303, chuyển trình duyệt tới trang HTML và chuyển client RDF tới Turtle, N-Triples, JSON-LD hoặc RDF/XML theo header Accept.</a:t>
+              <a:t>Nói: Liên kết lấy từ sitelink tiếng Anh của chính item Wikidata, không ghép theo tên vì tên Việt trùng nhiều. Có 777 liên kết sang DBpedia và 990 sang Wikidata. Nhóm kiểm tra cả 777 trên DBpedia thật: 733 trỏ đúng bài viết, 44 còn lại lệch vì DBpedia lấy dữ liệu từ bản Wikipedia cũ hơn.</a:t>
+            </a:r>
+          </a:p>
+          <a:p>
+            <a:r>
+              <a:t>Số phải trúng: 777 / 990; 733 (94,3%); 12 đổi hướng, 32 chưa có.</a:t>
+            </a:r>
+          </a:p>
+          <a:p>
+            <a:r>
+              <a:t>Nếu bị hỏi "sửa 44 liên kết thế nào?": 12 cái đi theo dbo:wikiPageRedirects là sửa được; 32 cái phải chờ bản DBpedia mới hoặc kiểm lại sau mỗi lần phát hành.</a:t>
             </a:r>
           </a:p>
         </p:txBody>
@@ -825,12 +831,7 @@
           <a:lstStyle/>
           <a:p>
             <a:r>
-              <a:t>Nói: Vậy dataset đạt đủ năm sao: giấy phép mở, máy đọc được, định dạng mở, URI cho mọi thứ, và liên kết sang DBpedia, Wikidata. Lưu ý duy nhất: nhóm không sở hữu tên miền vi.dbpedia.org, nên IRI chỉ mở được qua máy chủ của dự án.</a:t>
-            </a:r>
-          </a:p>
-          <a:p>
-            <a:r>
-              <a:t>Nếu bị hỏi "4 sao khác 3 sao ở đâu?": 3 sao là định dạng mở; 4 sao là dùng URI để định danh từng thứ, để người khác trỏ tới được.</a:t>
+              <a:t>Nói: Mỗi IRI tra được như DBpedia: máy chủ trả 303, chuyển trình duyệt tới trang HTML và chuyển client RDF tới Turtle, N-Triples, JSON-LD hoặc RDF/XML theo header Accept.</a:t>
             </a:r>
           </a:p>
         </p:txBody>
@@ -900,12 +901,12 @@
           <a:lstStyle/>
           <a:p>
             <a:r>
-              <a:t>Nói: Mình là Trung, phụ trách tầng máy chủ. Giao diện có bốn tab. Bên trái là trang tài nguyên giống dbpedia.org/page: lớp nào khai báo, lớp nào suy luận đều được đánh dấu. Bên phải là tab SPARQL, đang đếm số thực thể theo lớp DBpedia, toàn bộ đều có nhờ suy luận.</a:t>
-            </a:r>
-          </a:p>
-          <a:p>
-            <a:r>
-              <a:t>(Nếu demo: chuyển sang quay màn hình ở đây, xem phần "Demo trong video" ở trên.)</a:t>
+              <a:t>Nói: Vậy dataset đạt đủ năm sao: giấy phép mở, máy đọc được, định dạng mở, URI cho mọi thứ, và liên kết sang DBpedia, Wikidata. Lưu ý duy nhất: nhóm không sở hữu tên miền vi.dbpedia.org, nên IRI chỉ mở được qua máy chủ của dự án.</a:t>
+            </a:r>
+          </a:p>
+          <a:p>
+            <a:r>
+              <a:t>Nếu bị hỏi "vậy sao đã đủ 4 sao?": 4 sao đòi hỏi định danh bằng URI và tra được; IRI của nhóm dereference đúng chuẩn (303, content negotiation) trên máy chủ dự án; đưa lên Internet thật thì cần một tên miền của nhóm hoặc dịch vụ như w3id.org.</a:t>
             </a:r>
           </a:p>
         </p:txBody>
@@ -975,17 +976,12 @@
           <a:lstStyle/>
           <a:p>
             <a:r>
-              <a:t>Nói: Tab Hỏi đáp cho phép hỏi bằng tiếng Việt. Mô hình ngôn ngữ đọc tóm tắt schema, viết SPARQL; hệ thống chỉ chấp nhận SELECT hoặc ASK, chạy trên graph, rồi để mô hình trả lời từ kết quả. Nếu truy vấn lỗi hoặc rỗng, mô hình được sửa một lần.</a:t>
-            </a:r>
-          </a:p>
-          <a:p>
-            <a:r>
-              <a:t>Số phải trúng: 10,7 giây xuống 0,27 giây nhờ subquery.</a:t>
-            </a:r>
-          </a:p>
-          <a:p>
-            <a:r>
-              <a:t>Nếu bị hỏi "LLM viết sai truy vấn thì sao?": truy vấn được parse trước khi chạy, chỉ SELECT/ASK; lỗi hoặc rỗng thì gửi lại cho mô hình sửa một lần; SPARQL mode cho người dùng xem truy vấn thật.</a:t>
+              <a:t>Nói: Mình là Trung, phụ trách tầng máy chủ. Giao diện có bốn tab. Bên trái là trang tài nguyên giống dbpedia.org/page, đánh dấu lớp khai báo và lớp suy luận. Bên phải là tab SPARQL, đang đếm thực thể theo lớp DBpedia, toàn bộ có nhờ suy luận.</a:t>
+            </a:r>
+          </a:p>
+          <a:p>
+            <a:r>
+              <a:t>(Nếu demo: chuyển sang quay màn hình ở đây, xem phần "Demo trong video" ở trên.)</a:t>
             </a:r>
           </a:p>
         </p:txBody>
@@ -1055,12 +1051,17 @@
           <a:lstStyle/>
           <a:p>
             <a:r>
-              <a:t>Nói: Graph trả lời đúng các câu hỏi năng lực, ví dụ: hiện còn 34 tỉnh thành, Nghệ An có nhiều cầu thủ nhất với 58 người. Mỗi câu hỏi là một test tự động trên dữ liệu thật.</a:t>
-            </a:r>
-          </a:p>
-          <a:p>
-            <a:r>
-              <a:t>Số phải trúng: 34; Nghệ An 58; 11 đội của Công Phượng.</a:t>
+              <a:t>Nói: Tab Hỏi đáp cho phép hỏi bằng tiếng Việt. Mô hình ngôn ngữ đọc tóm tắt schema, viết SPARQL; hệ thống chỉ chấp nhận SELECT hoặc ASK, chạy trên graph, rồi để mô hình trả lời từ kết quả. Nếu truy vấn lỗi hoặc rỗng, mô hình được sửa một lần.</a:t>
+            </a:r>
+          </a:p>
+          <a:p>
+            <a:r>
+              <a:t>Số phải trúng: 10,7 giây xuống 0,27 giây nhờ subquery.</a:t>
+            </a:r>
+          </a:p>
+          <a:p>
+            <a:r>
+              <a:t>Nếu bị hỏi "LLM viết sai truy vấn thì sao?": truy vấn được parse trước khi chạy, chỉ SELECT/ASK; lỗi hoặc rỗng thì gửi lại cho mô hình sửa một lần; SPARQL mode cho người dùng xem truy vấn thật.</a:t>
             </a:r>
           </a:p>
         </p:txBody>
@@ -1130,12 +1131,12 @@
           <a:lstStyle/>
           <a:p>
             <a:r>
-              <a:t>Nói: Hạn chế chính: mới một miền, 44 liên kết cần sửa, và chưa có endpoint /sparql chuẩn. Hướng tiếp theo là thêm endpoint đó, thêm lớp mới và đo độ chính xác của tab Hỏi đáp.</a:t>
-            </a:r>
-          </a:p>
-          <a:p>
-            <a:r>
-              <a:t>Nếu bị hỏi "SPARQL endpoint ở đâu?": hiện truy vấn qua tab SPARQL trên giao diện; muốn có endpoint HTTP chuẩn thì nạp dump vào Virtuoso đã khai báo sẵn trong docker-compose.yml, cổng 8890.</a:t>
+              <a:t>Nói: Graph trả lời đúng các câu hỏi năng lực, ví dụ còn 34 tỉnh thành, Nghệ An nhiều cầu thủ nhất với 58 người. Mỗi câu là một test tự động.</a:t>
+            </a:r>
+          </a:p>
+          <a:p>
+            <a:r>
+              <a:t>Số phải trúng: 34; Nghệ An 58; 11 đội của Công Phượng.</a:t>
             </a:r>
           </a:p>
         </p:txBody>
@@ -1205,7 +1206,12 @@
           <a:lstStyle/>
           <a:p>
             <a:r>
-              <a:t>Nói: Tóm lại, nhóm đã xây dựng một DBpedia tiếng Việt năm sao cho ba miền dữ liệu. Suy luận OWL là thứ giúp dữ liệu dùng chung được với DBpedia. Mã nguồn và dữ liệu có trên GitHub.</a:t>
+              <a:t>Nói: Hạn chế chính: mới một miền, 44 liên kết cần sửa, và chưa có endpoint /sparql chuẩn. Hướng tiếp theo là thêm endpoint đó, thêm lớp mới và đo độ chính xác của tab Hỏi đáp.</a:t>
+            </a:r>
+          </a:p>
+          <a:p>
+            <a:r>
+              <a:t>Nếu bị hỏi "SPARQL endpoint ở đâu?": hiện truy vấn qua tab SPARQL trên giao diện; muốn có endpoint HTTP chuẩn thì nạp dump vào Virtuoso đã khai báo sẵn trong docker-compose.yml, cổng 8890.</a:t>
             </a:r>
           </a:p>
         </p:txBody>
@@ -1275,7 +1281,7 @@
           <a:lstStyle/>
           <a:p>
             <a:r>
-              <a:t>Nói: Cảm ơn thầy và các bạn đã lắng nghe.</a:t>
+              <a:t>Nói: Tóm lại, nhóm đã xây dựng một DBpedia tiếng Việt năm sao cho ba miền dữ liệu. Suy luận OWL là thứ giúp dữ liệu dùng chung được với DBpedia. Mã nguồn và dữ liệu có trên GitHub.</a:t>
             </a:r>
           </a:p>
         </p:txBody>
@@ -1375,6 +1381,76 @@
 </p:notes>
 </file>
 
+<file path=ppt/notesSlides/notesSlide20.xml><?xml version="1.0" encoding="utf-8"?>
+<p:notes xmlns:a="http://schemas.openxmlformats.org/drawingml/2006/main" xmlns:p="http://schemas.openxmlformats.org/presentationml/2006/main" xmlns:r="http://schemas.openxmlformats.org/officeDocument/2006/relationships">
+  <p:cSld>
+    <p:spTree>
+      <p:nvGrpSpPr>
+        <p:cNvPr id="1" name=""/>
+        <p:cNvGrpSpPr/>
+        <p:nvPr/>
+      </p:nvGrpSpPr>
+      <p:grpSpPr>
+        <a:xfrm>
+          <a:off x="0" y="0"/>
+          <a:ext cx="0" cy="0"/>
+          <a:chOff x="0" y="0"/>
+          <a:chExt cx="0" cy="0"/>
+        </a:xfrm>
+      </p:grpSpPr>
+      <p:sp>
+        <p:nvSpPr>
+          <p:cNvPr id="2" name="Slide Image Placeholder 1"/>
+          <p:cNvSpPr>
+            <a:spLocks noGrp="1"/>
+          </p:cNvSpPr>
+          <p:nvPr>
+            <p:ph type="sldImg" idx="2"/>
+          </p:nvPr>
+        </p:nvSpPr>
+        <p:spPr/>
+      </p:sp>
+      <p:sp>
+        <p:nvSpPr>
+          <p:cNvPr id="3" name="Notes Placeholder 2"/>
+          <p:cNvSpPr>
+            <a:spLocks noGrp="1"/>
+          </p:cNvSpPr>
+          <p:nvPr>
+            <p:ph type="body" idx="3" sz="quarter"/>
+          </p:nvPr>
+        </p:nvSpPr>
+        <p:spPr/>
+        <p:txBody>
+          <a:bodyPr/>
+          <a:lstStyle/>
+          <a:p>
+            <a:r>
+              <a:t>Nói: Cảm ơn thầy và các bạn đã lắng nghe.</a:t>
+            </a:r>
+          </a:p>
+        </p:txBody>
+      </p:sp>
+      <p:sp>
+        <p:nvSpPr>
+          <p:cNvPr id="4" name="Slide Number Placeholder 3"/>
+          <p:cNvSpPr>
+            <a:spLocks noGrp="1"/>
+          </p:cNvSpPr>
+          <p:nvPr>
+            <p:ph type="sldNum" idx="5" sz="quarter"/>
+          </p:nvPr>
+        </p:nvSpPr>
+        <p:spPr/>
+      </p:sp>
+    </p:spTree>
+  </p:cSld>
+  <p:clrMapOvr>
+    <a:masterClrMapping/>
+  </p:clrMapOvr>
+</p:notes>
+</file>
+
 <file path=ppt/notesSlides/notesSlide3.xml><?xml version="1.0" encoding="utf-8"?>
 <p:notes xmlns:a="http://schemas.openxmlformats.org/drawingml/2006/main" xmlns:p="http://schemas.openxmlformats.org/presentationml/2006/main" xmlns:r="http://schemas.openxmlformats.org/officeDocument/2006/relationships">
   <p:cSld>
@@ -1420,7 +1496,7 @@
           <a:lstStyle/>
           <a:p>
             <a:r>
-              <a:t>Nói: Miền được chọn là bóng đá Việt Nam, tỉnh thành và đại học. Các thực thể này trỏ lẫn nhau, nên trả lời được câu hỏi nhiều bước: cầu thủ, chặng thi đấu, câu lạc bộ, sân nhà, rồi tới tỉnh. 97% bài có infobox và 78% có bài tiếng Anh để liên kết.</a:t>
+              <a:t>Nói: Miền được chọn là bóng đá Việt Nam, tỉnh thành và đại học, vì các thực thể trỏ lẫn nhau: cầu thủ, câu lạc bộ, sân nhà, tỉnh. 97% bài có infobox, 78% có bài tiếng Anh để liên kết.</a:t>
             </a:r>
           </a:p>
           <a:p>
@@ -1500,7 +1576,7 @@
           <a:lstStyle/>
           <a:p>
             <a:r>
-              <a:t>Nói: Hệ thống có bốn tầng, mỗi bước là một lệnh, và bốn phần trình bày của nhóm đi theo đúng bốn tầng này. Chỉ tầng thu thập gọi mạng; mọi phản hồi được cache và dữ liệu thô được commit, nên dựng lại toàn bộ dataset mà không cần Internet, kết quả giống hệt nhau.</a:t>
+              <a:t>Nói: Hệ thống có bốn tầng, mỗi bước một lệnh, và bốn phần trình bày đi theo đúng bốn tầng này. Chỉ tầng thu thập gọi mạng; mọi thứ được cache nên dựng lại được mà không cần Internet.</a:t>
             </a:r>
           </a:p>
           <a:p>
@@ -1655,17 +1731,17 @@
           <a:lstStyle/>
           <a:p>
             <a:r>
-              <a:t>Nói: Mình là Hoang, phụ trách tầng ngữ nghĩa. Ontology có 18 lớp chia bốn cây: người, tổ chức, địa điểm và chặng thi đấu. Lớp nào cũng là lớp con của một lớp DBpedia. Dữ liệu khai báo chỉ dùng vio:, còn sau suy luận thì có cả lớp DBpedia, ví dụ dbo:Person từ 0 lên 659.</a:t>
-            </a:r>
-          </a:p>
-          <a:p>
-            <a:r>
-              <a:t>Số phải trúng: 54 thuộc tính, 38 là thuộc tính con của dbo:; 659; 486.</a:t>
-            </a:r>
-          </a:p>
-          <a:p>
-            <a:r>
-              <a:t>Nếu bị hỏi "sao không dùng thẳng dbo:?": DBpedia không có những khái niệm nhóm cần, như tỉnh cũ hay ba loại chặng thi đấu; lớp riêng cũng giữ cho tiên đề của nhóm chỉ ràng buộc dữ liệu của nhóm.</a:t>
+              <a:t>Nói: Mình là Hoang, phụ trách tầng ngữ nghĩa. Đây là một phần ontology vẽ dạng đồ thị RDFS. Phía trên đường kẻ là schema: lớp là rdfs:Class, thuộc tính là rdf:Property, nối bằng subClassOf và subPropertyOf; careerStation có domain là cầu thủ, range là chặng thi đấu. Phía dưới là dữ liệu: Công Phượng có chặng thi đấu ở Hoàng Anh Gia Lai, quê Nghệ An. Nét đứt là triple RDFS suy ra: Công Phượng cũng là dbo:Person.</a:t>
+            </a:r>
+          </a:p>
+          <a:p>
+            <a:r>
+              <a:t>Số phải trúng: toàn bộ ontology có 18 lớp, 54 thuộc tính; lớp nào cũng là lớp con của một lớp DBpedia.</a:t>
+            </a:r>
+          </a:p>
+          <a:p>
+            <a:r>
+              <a:t>Nếu bị hỏi "vì sao Công Phượng là dbo:Person?": luật rdfs9, kiểu được truyền lên theo subClassOf: FootballPlayer ⊑ Athlete ⊑ Person ⊑ dbo:Person.</a:t>
             </a:r>
           </a:p>
         </p:txBody>
@@ -1815,7 +1891,7 @@
           <a:lstStyle/>
           <a:p>
             <a:r>
-              <a:t>Nói: Infobox đi qua bốn bước: diễn giải template, đọc giá trị kiểu Việt như "16.361,2" hay dấu cho mượn, ánh xạ khoá sang vio:, rồi chọn Wikidata hay infobox cho từng thuộc tính. Các hàng năm, CLB, số trận, bàn thắng thành 3.382 chặng thi đấu. Nhóm tái tạo đủ các dataset cơ bản của DBpedia.</a:t>
+              <a:t>Nói: Infobox đi qua bốn bước: diễn giải template, đọc giá trị kiểu Việt như "16.361,2" hay dấu cho mượn, ánh xạ khoá sang vio:, rồi chọn Wikidata hay infobox cho từng thuộc tính. Các hàng năm, CLB, số trận, bàn thắng thành 3.382 chặng thi đấu.</a:t>
             </a:r>
           </a:p>
           <a:p>
@@ -1895,12 +1971,17 @@
           <a:lstStyle/>
           <a:p>
             <a:r>
-              <a:t>Nói: Mình là Dung, phụ trách tầng hậu xử lý. Đây là Nguyễn Công Phượng. Nét xám là dữ liệu khai báo: hai chặng thi đấu, đội, sân nhà Pleiku, tỉnh Gia Lai. Nét đỏ đứt là phần suy luận: các lớp DBpedia, cạnh playedFor, và Mito HollyHock được xếp vào lớp CLB. Nét xanh là liên kết ra ngoài.</a:t>
-            </a:r>
-          </a:p>
-          <a:p>
-            <a:r>
-              <a:t>Số phải trúng: 11 chặng thi đấu; 2015–2023, 103 trận, 36 bàn ở Hoàng Anh Gia Lai.</a:t>
+              <a:t>Nói: Đây là bước chuyển sang 4 sao trên một infobox thật. Phía trên là wikitext: máy đọc được nhưng chỉ là chữ, không có URI. Phía dưới là RDF: mỗi thứ có một IRI, kể cả chặng cho mượn ở Mito; giá trị có kiểu, như ngày sinh là xsd:date; dấu "mượn" thành onLoan true; còn chiều cao lấy theo Wikidata là 1,68 thay vì 1,69 của infobox.</a:t>
+            </a:r>
+          </a:p>
+          <a:p>
+            <a:r>
+              <a:t>Số phải trúng: 21/01/1995; Mito HollyHock 2016, 5 trận, 0 bàn, cho mượn.</a:t>
+            </a:r>
+          </a:p>
+          <a:p>
+            <a:r>
+              <a:t>Nếu bị hỏi "3 sao khác 4 sao ở đâu?": 3 sao là định dạng mở như CSV hay JSON; 4 sao là dùng URI để định danh từng thứ, để người khác trỏ tới và tra được (303 ở slide 13).</a:t>
             </a:r>
           </a:p>
         </p:txBody>
@@ -5359,6 +5440,48 @@
 </file>
 
 <file path=ppt/slides/slide2.xml><?xml version="1.0" encoding="utf-8"?>
+<p:sld xmlns:a="http://schemas.openxmlformats.org/drawingml/2006/main" xmlns:p="http://schemas.openxmlformats.org/presentationml/2006/main" xmlns:r="http://schemas.openxmlformats.org/officeDocument/2006/relationships">
+  <p:cSld>
+    <p:spTree>
+      <p:nvGrpSpPr>
+        <p:cNvPr id="1" name=""/>
+        <p:cNvGrpSpPr/>
+        <p:nvPr/>
+      </p:nvGrpSpPr>
+      <p:grpSpPr/>
+      <p:pic>
+        <p:nvPicPr>
+          <p:cNvPr id="2" name="Picture 1" descr="image.png"/>
+          <p:cNvPicPr>
+            <a:picLocks noChangeAspect="1"/>
+          </p:cNvPicPr>
+          <p:nvPr/>
+        </p:nvPicPr>
+        <p:blipFill>
+          <a:blip r:embed="rId2"/>
+          <a:stretch>
+            <a:fillRect/>
+          </a:stretch>
+        </p:blipFill>
+        <p:spPr>
+          <a:xfrm>
+            <a:off x="0" y="0"/>
+            <a:ext cx="9144000" cy="6857994"/>
+          </a:xfrm>
+          <a:prstGeom prst="rect">
+            <a:avLst/>
+          </a:prstGeom>
+        </p:spPr>
+      </p:pic>
+    </p:spTree>
+  </p:cSld>
+  <p:clrMapOvr>
+    <a:masterClrMapping/>
+  </p:clrMapOvr>
+</p:sld>
+</file>
+
+<file path=ppt/slides/slide20.xml><?xml version="1.0" encoding="utf-8"?>
 <p:sld xmlns:a="http://schemas.openxmlformats.org/drawingml/2006/main" xmlns:p="http://schemas.openxmlformats.org/presentationml/2006/main" xmlns:r="http://schemas.openxmlformats.org/officeDocument/2006/relationships">
   <p:cSld>
     <p:spTree>

</xml_diff>